<commit_message>
Zmiany tesktu w prezentacji 1
</commit_message>
<xml_diff>
--- a/dokumenty-ur/prezentacje/prezentacja_zalozen_pracy.pptx
+++ b/dokumenty-ur/prezentacje/prezentacja_zalozen_pracy.pptx
@@ -2695,7 +2695,7 @@
               <a:t> </a:t>
             </a:r>
             <a:r>
-              <a:rPr lang="pl-PL" sz="1800">
+              <a:rPr lang="pl-PL" sz="1800" dirty="0">
                 <a:solidFill>
                   <a:srgbClr val="1F2A44"/>
                 </a:solidFill>
@@ -2706,17 +2706,6 @@
               <a:t>przydział</a:t>
             </a:r>
             <a:r>
-              <a:rPr lang="en-US" sz="1800">
-                <a:solidFill>
-                  <a:srgbClr val="1F2A44"/>
-                </a:solidFill>
-                <a:latin typeface="Calibri" pitchFamily="34" charset="0"/>
-                <a:ea typeface="Calibri" pitchFamily="34" charset="-122"/>
-                <a:cs typeface="Calibri" pitchFamily="34" charset="-120"/>
-              </a:rPr>
-              <a:t> </a:t>
-            </a:r>
-            <a:r>
               <a:rPr lang="en-US" sz="1800" dirty="0">
                 <a:solidFill>
                   <a:srgbClr val="1F2A44"/>
@@ -2725,7 +2714,7 @@
                 <a:ea typeface="Calibri" pitchFamily="34" charset="-122"/>
                 <a:cs typeface="Calibri" pitchFamily="34" charset="-120"/>
               </a:rPr>
-              <a:t>innych</a:t>
+              <a:t> innych</a:t>
             </a:r>
             <a:endParaRPr lang="en-US" sz="1800" dirty="0"/>
           </a:p>
@@ -3692,7 +3681,29 @@
                 <a:ea typeface="Calibri" pitchFamily="34" charset="-122"/>
                 <a:cs typeface="Calibri" pitchFamily="34" charset="-120"/>
               </a:rPr>
-              <a:t>Co można zaimplementować? (propozycje, nie finalny wybór)</a:t>
+              <a:t>Co można </a:t>
+            </a:r>
+            <a:r>
+              <a:rPr lang="en-US" sz="1400" dirty="0" err="1">
+                <a:solidFill>
+                  <a:srgbClr val="0E7C86"/>
+                </a:solidFill>
+                <a:latin typeface="Calibri" pitchFamily="34" charset="0"/>
+                <a:ea typeface="Calibri" pitchFamily="34" charset="-122"/>
+                <a:cs typeface="Calibri" pitchFamily="34" charset="-120"/>
+              </a:rPr>
+              <a:t>zaimplementować</a:t>
+            </a:r>
+            <a:r>
+              <a:rPr lang="en-US" sz="1400" dirty="0">
+                <a:solidFill>
+                  <a:srgbClr val="0E7C86"/>
+                </a:solidFill>
+                <a:latin typeface="Calibri" pitchFamily="34" charset="0"/>
+                <a:ea typeface="Calibri" pitchFamily="34" charset="-122"/>
+                <a:cs typeface="Calibri" pitchFamily="34" charset="-120"/>
+              </a:rPr>
+              <a:t>?</a:t>
             </a:r>
             <a:endParaRPr lang="en-US" sz="1400" dirty="0"/>
           </a:p>
@@ -4266,6 +4277,28 @@
               <a:buNone/>
             </a:pPr>
             <a:r>
+              <a:rPr lang="pl-PL" sz="1300" dirty="0">
+                <a:solidFill>
+                  <a:srgbClr val="5B6475"/>
+                </a:solidFill>
+                <a:latin typeface="Calibri" pitchFamily="34" charset="0"/>
+                <a:ea typeface="Calibri" pitchFamily="34" charset="-122"/>
+                <a:cs typeface="Calibri" pitchFamily="34" charset="-120"/>
+              </a:rPr>
+              <a:t>M</a:t>
+            </a:r>
+            <a:r>
+              <a:rPr lang="en-US" sz="1300" dirty="0" err="1">
+                <a:solidFill>
+                  <a:srgbClr val="5B6475"/>
+                </a:solidFill>
+                <a:latin typeface="Calibri" pitchFamily="34" charset="0"/>
+                <a:ea typeface="Calibri" pitchFamily="34" charset="-122"/>
+                <a:cs typeface="Calibri" pitchFamily="34" charset="-120"/>
+              </a:rPr>
+              <a:t>inimalizacja</a:t>
+            </a:r>
+            <a:r>
               <a:rPr lang="en-US" sz="1300" dirty="0">
                 <a:solidFill>
                   <a:srgbClr val="5B6475"/>
@@ -4274,7 +4307,62 @@
                 <a:ea typeface="Calibri" pitchFamily="34" charset="-122"/>
                 <a:cs typeface="Calibri" pitchFamily="34" charset="-120"/>
               </a:rPr>
-              <a:t>Programowanie całkowitoliczbowe: minimalizacja niespełnionych preferencji przy ograniczeniach.</a:t>
+              <a:t> niespełnionych preferencji </a:t>
+            </a:r>
+            <a:r>
+              <a:rPr lang="en-US" sz="1300" dirty="0" err="1">
+                <a:solidFill>
+                  <a:srgbClr val="5B6475"/>
+                </a:solidFill>
+                <a:latin typeface="Calibri" pitchFamily="34" charset="0"/>
+                <a:ea typeface="Calibri" pitchFamily="34" charset="-122"/>
+                <a:cs typeface="Calibri" pitchFamily="34" charset="-120"/>
+              </a:rPr>
+              <a:t>przy</a:t>
+            </a:r>
+            <a:r>
+              <a:rPr lang="en-US" sz="1300" dirty="0">
+                <a:solidFill>
+                  <a:srgbClr val="5B6475"/>
+                </a:solidFill>
+                <a:latin typeface="Calibri" pitchFamily="34" charset="0"/>
+                <a:ea typeface="Calibri" pitchFamily="34" charset="-122"/>
+                <a:cs typeface="Calibri" pitchFamily="34" charset="-120"/>
+              </a:rPr>
+              <a:t> </a:t>
+            </a:r>
+            <a:r>
+              <a:rPr lang="pl-PL" sz="1300" dirty="0">
+                <a:solidFill>
+                  <a:srgbClr val="5B6475"/>
+                </a:solidFill>
+                <a:latin typeface="Calibri" pitchFamily="34" charset="0"/>
+                <a:ea typeface="Calibri" pitchFamily="34" charset="-122"/>
+                <a:cs typeface="Calibri" pitchFamily="34" charset="-120"/>
+              </a:rPr>
+              <a:t>podanych </a:t>
+            </a:r>
+            <a:r>
+              <a:rPr lang="en-US" sz="1300" dirty="0" err="1">
+                <a:solidFill>
+                  <a:srgbClr val="5B6475"/>
+                </a:solidFill>
+                <a:latin typeface="Calibri" pitchFamily="34" charset="0"/>
+                <a:ea typeface="Calibri" pitchFamily="34" charset="-122"/>
+                <a:cs typeface="Calibri" pitchFamily="34" charset="-120"/>
+              </a:rPr>
+              <a:t>ograniczeniach</a:t>
+            </a:r>
+            <a:r>
+              <a:rPr lang="en-US" sz="1300" dirty="0">
+                <a:solidFill>
+                  <a:srgbClr val="5B6475"/>
+                </a:solidFill>
+                <a:latin typeface="Calibri" pitchFamily="34" charset="0"/>
+                <a:ea typeface="Calibri" pitchFamily="34" charset="-122"/>
+                <a:cs typeface="Calibri" pitchFamily="34" charset="-120"/>
+              </a:rPr>
+              <a:t>.</a:t>
             </a:r>
             <a:endParaRPr lang="en-US" sz="1600" dirty="0"/>
           </a:p>
@@ -4632,6 +4720,17 @@
               <a:buChar char="•"/>
             </a:pPr>
             <a:r>
+              <a:rPr lang="pl-PL" sz="1800" dirty="0">
+                <a:solidFill>
+                  <a:srgbClr val="1F2A44"/>
+                </a:solidFill>
+                <a:latin typeface="Calibri" pitchFamily="34" charset="0"/>
+                <a:ea typeface="Calibri" pitchFamily="34" charset="-122"/>
+                <a:cs typeface="Calibri" pitchFamily="34" charset="-120"/>
+              </a:rPr>
+              <a:t>Przekazywanie danych</a:t>
+            </a:r>
+            <a:r>
               <a:rPr lang="en-US" sz="1800" dirty="0">
                 <a:solidFill>
                   <a:srgbClr val="1F2A44"/>
@@ -4640,7 +4739,7 @@
                 <a:ea typeface="Calibri" pitchFamily="34" charset="-122"/>
                 <a:cs typeface="Calibri" pitchFamily="34" charset="-120"/>
               </a:rPr>
-              <a:t>Wyniki w plikach (CSV/JSON) lub przez </a:t>
+              <a:t> w plikach (CSV/JSON) lub przez </a:t>
             </a:r>
             <a:r>
               <a:rPr lang="en-US" sz="1800" dirty="0" err="1">
@@ -5580,7 +5679,18 @@
                 <a:ea typeface="Calibri" pitchFamily="34" charset="-122"/>
                 <a:cs typeface="Calibri" pitchFamily="34" charset="-120"/>
               </a:rPr>
-              <a:t>Oczekiwane rezultaty i kompromisy</a:t>
+              <a:t>Oczekiwane </a:t>
+            </a:r>
+            <a:r>
+              <a:rPr lang="en-US" sz="2600" b="1" dirty="0" err="1">
+                <a:solidFill>
+                  <a:srgbClr val="1F2A44"/>
+                </a:solidFill>
+                <a:latin typeface="Calibri" pitchFamily="34" charset="0"/>
+                <a:ea typeface="Calibri" pitchFamily="34" charset="-122"/>
+                <a:cs typeface="Calibri" pitchFamily="34" charset="-120"/>
+              </a:rPr>
+              <a:t>rezultaty</a:t>
             </a:r>
             <a:endParaRPr lang="en-US" sz="2600" dirty="0"/>
           </a:p>

</xml_diff>